<commit_message>
fix: accurate competitor research — AppsFlyer, Singular, Segwise, VidMob, CreativeX, Motion
- AppsFlyer: element analysis (scenes/text/visuals/audio) + similarity grouping, NOT pHash
- Replaced Adjust + MagicBrief with CreativeX (governance) + Motion (SMB analytics)
- Corrected VidMob: direct ad platform APIs, no MMP required
- Segwise: 200+ tags, unique playable ad support, requires MMP integration
- PPT competitor table updated with verified feature data
- Added subtitle note clarifying AppsFlyer similarity vs pHash distinction
</commit_message>
<xml_diff>
--- a/docs/Creative-Intelligence-Platform-Pitch.pptx
+++ b/docs/Creative-Intelligence-Platform-Pitch.pptx
@@ -5350,7 +5350,7 @@
         <p:spPr>
           <a:xfrm>
             <a:off x="457200" y="256032"/>
-            <a:ext cx="10972800" cy="777240"/>
+            <a:ext cx="10058400" cy="777240"/>
           </a:xfrm>
           <a:prstGeom prst="rect">
             <a:avLst/>
@@ -5377,7 +5377,41 @@
       </p:sp>
       <p:sp>
         <p:nvSpPr>
-          <p:cNvPr id="4" name="Rectangle 3"/>
+          <p:cNvPr id="4" name="TextBox 3"/>
+          <p:cNvSpPr txBox="1"/>
+          <p:nvPr/>
+        </p:nvSpPr>
+        <p:spPr>
+          <a:xfrm>
+            <a:off x="457200" y="868680"/>
+            <a:ext cx="11247120" cy="320040"/>
+          </a:xfrm>
+          <a:prstGeom prst="rect">
+            <a:avLst/>
+          </a:prstGeom>
+          <a:noFill/>
+        </p:spPr>
+        <p:txBody>
+          <a:bodyPr wrap="square">
+            <a:spAutoFit/>
+          </a:bodyPr>
+          <a:lstStyle/>
+          <a:p>
+            <a:pPr algn="l"/>
+            <a:r>
+              <a:rPr sz="1100" b="0" i="1">
+                <a:solidFill>
+                  <a:srgbClr val="A8C4E8"/>
+                </a:solidFill>
+              </a:rPr>
+              <a:t>AppsFlyer has element analysis + similarity grouping — not pHash. No competitor has annotation, NL explanation, or on-premise.</a:t>
+            </a:r>
+          </a:p>
+        </p:txBody>
+      </p:sp>
+      <p:sp>
+        <p:nvSpPr>
+          <p:cNvPr id="5" name="Rectangle 4"/>
           <p:cNvSpPr/>
           <p:nvPr/>
         </p:nvSpPr>
@@ -5420,7 +5454,7 @@
       </p:sp>
       <p:sp>
         <p:nvSpPr>
-          <p:cNvPr id="5" name="TextBox 4"/>
+          <p:cNvPr id="6" name="TextBox 5"/>
           <p:cNvSpPr txBox="1"/>
           <p:nvPr/>
         </p:nvSpPr>
@@ -5454,7 +5488,7 @@
       </p:sp>
       <p:sp>
         <p:nvSpPr>
-          <p:cNvPr id="6" name="Rectangle 5"/>
+          <p:cNvPr id="7" name="Rectangle 6"/>
           <p:cNvSpPr/>
           <p:nvPr/>
         </p:nvSpPr>
@@ -5497,7 +5531,7 @@
       </p:sp>
       <p:sp>
         <p:nvSpPr>
-          <p:cNvPr id="7" name="TextBox 6"/>
+          <p:cNvPr id="8" name="TextBox 7"/>
           <p:cNvSpPr txBox="1"/>
           <p:nvPr/>
         </p:nvSpPr>
@@ -5531,7 +5565,7 @@
       </p:sp>
       <p:sp>
         <p:nvSpPr>
-          <p:cNvPr id="8" name="Rectangle 7"/>
+          <p:cNvPr id="9" name="Rectangle 8"/>
           <p:cNvSpPr/>
           <p:nvPr/>
         </p:nvSpPr>
@@ -5574,7 +5608,7 @@
       </p:sp>
       <p:sp>
         <p:nvSpPr>
-          <p:cNvPr id="9" name="TextBox 8"/>
+          <p:cNvPr id="10" name="TextBox 9"/>
           <p:cNvSpPr txBox="1"/>
           <p:nvPr/>
         </p:nvSpPr>
@@ -5608,7 +5642,7 @@
       </p:sp>
       <p:sp>
         <p:nvSpPr>
-          <p:cNvPr id="10" name="Rectangle 9"/>
+          <p:cNvPr id="11" name="Rectangle 10"/>
           <p:cNvSpPr/>
           <p:nvPr/>
         </p:nvSpPr>
@@ -5651,7 +5685,7 @@
       </p:sp>
       <p:sp>
         <p:nvSpPr>
-          <p:cNvPr id="11" name="TextBox 10"/>
+          <p:cNvPr id="12" name="TextBox 11"/>
           <p:cNvSpPr txBox="1"/>
           <p:nvPr/>
         </p:nvSpPr>
@@ -5685,7 +5719,7 @@
       </p:sp>
       <p:sp>
         <p:nvSpPr>
-          <p:cNvPr id="12" name="Rectangle 11"/>
+          <p:cNvPr id="13" name="Rectangle 12"/>
           <p:cNvSpPr/>
           <p:nvPr/>
         </p:nvSpPr>
@@ -5728,7 +5762,7 @@
       </p:sp>
       <p:sp>
         <p:nvSpPr>
-          <p:cNvPr id="13" name="TextBox 12"/>
+          <p:cNvPr id="14" name="TextBox 13"/>
           <p:cNvSpPr txBox="1"/>
           <p:nvPr/>
         </p:nvSpPr>
@@ -5762,7 +5796,7 @@
       </p:sp>
       <p:sp>
         <p:nvSpPr>
-          <p:cNvPr id="14" name="Rectangle 13"/>
+          <p:cNvPr id="15" name="Rectangle 14"/>
           <p:cNvSpPr/>
           <p:nvPr/>
         </p:nvSpPr>
@@ -5805,7 +5839,7 @@
       </p:sp>
       <p:sp>
         <p:nvSpPr>
-          <p:cNvPr id="15" name="TextBox 14"/>
+          <p:cNvPr id="16" name="TextBox 15"/>
           <p:cNvSpPr txBox="1"/>
           <p:nvPr/>
         </p:nvSpPr>
@@ -5839,7 +5873,7 @@
       </p:sp>
       <p:sp>
         <p:nvSpPr>
-          <p:cNvPr id="16" name="Rectangle 15"/>
+          <p:cNvPr id="17" name="Rectangle 16"/>
           <p:cNvSpPr/>
           <p:nvPr/>
         </p:nvSpPr>
@@ -5884,7 +5918,7 @@
       </p:sp>
       <p:sp>
         <p:nvSpPr>
-          <p:cNvPr id="17" name="TextBox 16"/>
+          <p:cNvPr id="18" name="TextBox 17"/>
           <p:cNvSpPr txBox="1"/>
           <p:nvPr/>
         </p:nvSpPr>
@@ -5918,7 +5952,7 @@
       </p:sp>
       <p:sp>
         <p:nvSpPr>
-          <p:cNvPr id="18" name="Rectangle 17"/>
+          <p:cNvPr id="19" name="Rectangle 18"/>
           <p:cNvSpPr/>
           <p:nvPr/>
         </p:nvSpPr>
@@ -5963,7 +5997,7 @@
       </p:sp>
       <p:sp>
         <p:nvSpPr>
-          <p:cNvPr id="19" name="TextBox 18"/>
+          <p:cNvPr id="20" name="TextBox 19"/>
           <p:cNvSpPr txBox="1"/>
           <p:nvPr/>
         </p:nvSpPr>
@@ -5997,7 +6031,7 @@
       </p:sp>
       <p:sp>
         <p:nvSpPr>
-          <p:cNvPr id="20" name="Rectangle 19"/>
+          <p:cNvPr id="21" name="Rectangle 20"/>
           <p:cNvSpPr/>
           <p:nvPr/>
         </p:nvSpPr>
@@ -6042,7 +6076,7 @@
       </p:sp>
       <p:sp>
         <p:nvSpPr>
-          <p:cNvPr id="21" name="TextBox 20"/>
+          <p:cNvPr id="22" name="TextBox 21"/>
           <p:cNvSpPr txBox="1"/>
           <p:nvPr/>
         </p:nvSpPr>
@@ -6076,7 +6110,7 @@
       </p:sp>
       <p:sp>
         <p:nvSpPr>
-          <p:cNvPr id="22" name="Rectangle 21"/>
+          <p:cNvPr id="23" name="Rectangle 22"/>
           <p:cNvSpPr/>
           <p:nvPr/>
         </p:nvSpPr>
@@ -6121,7 +6155,7 @@
       </p:sp>
       <p:sp>
         <p:nvSpPr>
-          <p:cNvPr id="23" name="TextBox 22"/>
+          <p:cNvPr id="24" name="TextBox 23"/>
           <p:cNvSpPr txBox="1"/>
           <p:nvPr/>
         </p:nvSpPr>
@@ -6155,7 +6189,7 @@
       </p:sp>
       <p:sp>
         <p:nvSpPr>
-          <p:cNvPr id="24" name="Rectangle 23"/>
+          <p:cNvPr id="25" name="Rectangle 24"/>
           <p:cNvSpPr/>
           <p:nvPr/>
         </p:nvSpPr>
@@ -6200,7 +6234,7 @@
       </p:sp>
       <p:sp>
         <p:nvSpPr>
-          <p:cNvPr id="25" name="TextBox 24"/>
+          <p:cNvPr id="26" name="TextBox 25"/>
           <p:cNvSpPr txBox="1"/>
           <p:nvPr/>
         </p:nvSpPr>
@@ -6234,7 +6268,7 @@
       </p:sp>
       <p:sp>
         <p:nvSpPr>
-          <p:cNvPr id="26" name="Rectangle 25"/>
+          <p:cNvPr id="27" name="Rectangle 26"/>
           <p:cNvSpPr/>
           <p:nvPr/>
         </p:nvSpPr>
@@ -6279,7 +6313,7 @@
       </p:sp>
       <p:sp>
         <p:nvSpPr>
-          <p:cNvPr id="27" name="TextBox 26"/>
+          <p:cNvPr id="28" name="TextBox 27"/>
           <p:cNvSpPr txBox="1"/>
           <p:nvPr/>
         </p:nvSpPr>
@@ -6313,7 +6347,7 @@
       </p:sp>
       <p:sp>
         <p:nvSpPr>
-          <p:cNvPr id="28" name="Rectangle 27"/>
+          <p:cNvPr id="29" name="Rectangle 28"/>
           <p:cNvSpPr/>
           <p:nvPr/>
         </p:nvSpPr>
@@ -6358,7 +6392,7 @@
       </p:sp>
       <p:sp>
         <p:nvSpPr>
-          <p:cNvPr id="29" name="TextBox 28"/>
+          <p:cNvPr id="30" name="TextBox 29"/>
           <p:cNvSpPr txBox="1"/>
           <p:nvPr/>
         </p:nvSpPr>
@@ -6385,14 +6419,14 @@
                   <a:srgbClr val="1A1B1C"/>
                 </a:solidFill>
               </a:rPr>
-              <a:t>Natural Language Why</a:t>
-            </a:r>
-          </a:p>
-        </p:txBody>
-      </p:sp>
-      <p:sp>
-        <p:nvSpPr>
-          <p:cNvPr id="30" name="Rectangle 29"/>
+              <a:t>Natural Language 'Why'</a:t>
+            </a:r>
+          </a:p>
+        </p:txBody>
+      </p:sp>
+      <p:sp>
+        <p:nvSpPr>
+          <p:cNvPr id="31" name="Rectangle 30"/>
           <p:cNvSpPr/>
           <p:nvPr/>
         </p:nvSpPr>
@@ -6437,7 +6471,7 @@
       </p:sp>
       <p:sp>
         <p:nvSpPr>
-          <p:cNvPr id="31" name="TextBox 30"/>
+          <p:cNvPr id="32" name="TextBox 31"/>
           <p:cNvSpPr txBox="1"/>
           <p:nvPr/>
         </p:nvSpPr>
@@ -6471,7 +6505,7 @@
       </p:sp>
       <p:sp>
         <p:nvSpPr>
-          <p:cNvPr id="32" name="Rectangle 31"/>
+          <p:cNvPr id="33" name="Rectangle 32"/>
           <p:cNvSpPr/>
           <p:nvPr/>
         </p:nvSpPr>
@@ -6516,7 +6550,7 @@
       </p:sp>
       <p:sp>
         <p:nvSpPr>
-          <p:cNvPr id="33" name="TextBox 32"/>
+          <p:cNvPr id="34" name="TextBox 33"/>
           <p:cNvSpPr txBox="1"/>
           <p:nvPr/>
         </p:nvSpPr>
@@ -6550,7 +6584,7 @@
       </p:sp>
       <p:sp>
         <p:nvSpPr>
-          <p:cNvPr id="34" name="Rectangle 33"/>
+          <p:cNvPr id="35" name="Rectangle 34"/>
           <p:cNvSpPr/>
           <p:nvPr/>
         </p:nvSpPr>
@@ -6595,7 +6629,7 @@
       </p:sp>
       <p:sp>
         <p:nvSpPr>
-          <p:cNvPr id="35" name="TextBox 34"/>
+          <p:cNvPr id="36" name="TextBox 35"/>
           <p:cNvSpPr txBox="1"/>
           <p:nvPr/>
         </p:nvSpPr>
@@ -6629,7 +6663,7 @@
       </p:sp>
       <p:sp>
         <p:nvSpPr>
-          <p:cNvPr id="36" name="Rectangle 35"/>
+          <p:cNvPr id="37" name="Rectangle 36"/>
           <p:cNvSpPr/>
           <p:nvPr/>
         </p:nvSpPr>
@@ -6674,7 +6708,7 @@
       </p:sp>
       <p:sp>
         <p:nvSpPr>
-          <p:cNvPr id="37" name="TextBox 36"/>
+          <p:cNvPr id="38" name="TextBox 37"/>
           <p:cNvSpPr txBox="1"/>
           <p:nvPr/>
         </p:nvSpPr>
@@ -6708,7 +6742,7 @@
       </p:sp>
       <p:sp>
         <p:nvSpPr>
-          <p:cNvPr id="38" name="Rectangle 37"/>
+          <p:cNvPr id="39" name="Rectangle 38"/>
           <p:cNvSpPr/>
           <p:nvPr/>
         </p:nvSpPr>
@@ -6753,7 +6787,7 @@
       </p:sp>
       <p:sp>
         <p:nvSpPr>
-          <p:cNvPr id="39" name="TextBox 38"/>
+          <p:cNvPr id="40" name="TextBox 39"/>
           <p:cNvSpPr txBox="1"/>
           <p:nvPr/>
         </p:nvSpPr>
@@ -6787,7 +6821,7 @@
       </p:sp>
       <p:sp>
         <p:nvSpPr>
-          <p:cNvPr id="40" name="Rectangle 39"/>
+          <p:cNvPr id="41" name="Rectangle 40"/>
           <p:cNvSpPr/>
           <p:nvPr/>
         </p:nvSpPr>
@@ -6832,7 +6866,7 @@
       </p:sp>
       <p:sp>
         <p:nvSpPr>
-          <p:cNvPr id="41" name="TextBox 40"/>
+          <p:cNvPr id="42" name="TextBox 41"/>
           <p:cNvSpPr txBox="1"/>
           <p:nvPr/>
         </p:nvSpPr>
@@ -6866,7 +6900,7 @@
       </p:sp>
       <p:sp>
         <p:nvSpPr>
-          <p:cNvPr id="42" name="Rectangle 41"/>
+          <p:cNvPr id="43" name="Rectangle 42"/>
           <p:cNvSpPr/>
           <p:nvPr/>
         </p:nvSpPr>
@@ -6911,7 +6945,7 @@
       </p:sp>
       <p:sp>
         <p:nvSpPr>
-          <p:cNvPr id="43" name="TextBox 42"/>
+          <p:cNvPr id="44" name="TextBox 43"/>
           <p:cNvSpPr txBox="1"/>
           <p:nvPr/>
         </p:nvSpPr>
@@ -6945,7 +6979,7 @@
       </p:sp>
       <p:sp>
         <p:nvSpPr>
-          <p:cNvPr id="44" name="Rectangle 43"/>
+          <p:cNvPr id="45" name="Rectangle 44"/>
           <p:cNvSpPr/>
           <p:nvPr/>
         </p:nvSpPr>
@@ -6990,7 +7024,7 @@
       </p:sp>
       <p:sp>
         <p:nvSpPr>
-          <p:cNvPr id="45" name="TextBox 44"/>
+          <p:cNvPr id="46" name="TextBox 45"/>
           <p:cNvSpPr txBox="1"/>
           <p:nvPr/>
         </p:nvSpPr>
@@ -7024,7 +7058,7 @@
       </p:sp>
       <p:sp>
         <p:nvSpPr>
-          <p:cNvPr id="46" name="Rectangle 45"/>
+          <p:cNvPr id="47" name="Rectangle 46"/>
           <p:cNvSpPr/>
           <p:nvPr/>
         </p:nvSpPr>
@@ -7069,7 +7103,7 @@
       </p:sp>
       <p:sp>
         <p:nvSpPr>
-          <p:cNvPr id="47" name="TextBox 46"/>
+          <p:cNvPr id="48" name="TextBox 47"/>
           <p:cNvSpPr txBox="1"/>
           <p:nvPr/>
         </p:nvSpPr>
@@ -7103,7 +7137,7 @@
       </p:sp>
       <p:sp>
         <p:nvSpPr>
-          <p:cNvPr id="48" name="Rectangle 47"/>
+          <p:cNvPr id="49" name="Rectangle 48"/>
           <p:cNvSpPr/>
           <p:nvPr/>
         </p:nvSpPr>
@@ -7148,7 +7182,7 @@
       </p:sp>
       <p:sp>
         <p:nvSpPr>
-          <p:cNvPr id="49" name="TextBox 48"/>
+          <p:cNvPr id="50" name="TextBox 49"/>
           <p:cNvSpPr txBox="1"/>
           <p:nvPr/>
         </p:nvSpPr>
@@ -7182,7 +7216,7 @@
       </p:sp>
       <p:sp>
         <p:nvSpPr>
-          <p:cNvPr id="50" name="Rectangle 49"/>
+          <p:cNvPr id="51" name="Rectangle 50"/>
           <p:cNvSpPr/>
           <p:nvPr/>
         </p:nvSpPr>
@@ -7227,7 +7261,7 @@
       </p:sp>
       <p:sp>
         <p:nvSpPr>
-          <p:cNvPr id="51" name="TextBox 50"/>
+          <p:cNvPr id="52" name="TextBox 51"/>
           <p:cNvSpPr txBox="1"/>
           <p:nvPr/>
         </p:nvSpPr>
@@ -7261,7 +7295,7 @@
       </p:sp>
       <p:sp>
         <p:nvSpPr>
-          <p:cNvPr id="52" name="Rectangle 51"/>
+          <p:cNvPr id="53" name="Rectangle 52"/>
           <p:cNvSpPr/>
           <p:nvPr/>
         </p:nvSpPr>
@@ -7306,7 +7340,7 @@
       </p:sp>
       <p:sp>
         <p:nvSpPr>
-          <p:cNvPr id="53" name="TextBox 52"/>
+          <p:cNvPr id="54" name="TextBox 53"/>
           <p:cNvSpPr txBox="1"/>
           <p:nvPr/>
         </p:nvSpPr>
@@ -7333,14 +7367,14 @@
                   <a:srgbClr val="1A1B1C"/>
                 </a:solidFill>
               </a:rPr>
-              <a:t>Duplicate Detection</a:t>
-            </a:r>
-          </a:p>
-        </p:txBody>
-      </p:sp>
-      <p:sp>
-        <p:nvSpPr>
-          <p:cNvPr id="54" name="Rectangle 53"/>
+              <a:t>pHash Duplicate Detection</a:t>
+            </a:r>
+          </a:p>
+        </p:txBody>
+      </p:sp>
+      <p:sp>
+        <p:nvSpPr>
+          <p:cNvPr id="55" name="Rectangle 54"/>
           <p:cNvSpPr/>
           <p:nvPr/>
         </p:nvSpPr>
@@ -7385,7 +7419,7 @@
       </p:sp>
       <p:sp>
         <p:nvSpPr>
-          <p:cNvPr id="55" name="TextBox 54"/>
+          <p:cNvPr id="56" name="TextBox 55"/>
           <p:cNvSpPr txBox="1"/>
           <p:nvPr/>
         </p:nvSpPr>
@@ -7419,7 +7453,7 @@
       </p:sp>
       <p:sp>
         <p:nvSpPr>
-          <p:cNvPr id="56" name="Rectangle 55"/>
+          <p:cNvPr id="57" name="Rectangle 56"/>
           <p:cNvSpPr/>
           <p:nvPr/>
         </p:nvSpPr>
@@ -7464,7 +7498,7 @@
       </p:sp>
       <p:sp>
         <p:nvSpPr>
-          <p:cNvPr id="57" name="TextBox 56"/>
+          <p:cNvPr id="58" name="TextBox 57"/>
           <p:cNvSpPr txBox="1"/>
           <p:nvPr/>
         </p:nvSpPr>
@@ -7498,7 +7532,7 @@
       </p:sp>
       <p:sp>
         <p:nvSpPr>
-          <p:cNvPr id="58" name="Rectangle 57"/>
+          <p:cNvPr id="59" name="Rectangle 58"/>
           <p:cNvSpPr/>
           <p:nvPr/>
         </p:nvSpPr>
@@ -7543,7 +7577,7 @@
       </p:sp>
       <p:sp>
         <p:nvSpPr>
-          <p:cNvPr id="59" name="TextBox 58"/>
+          <p:cNvPr id="60" name="TextBox 59"/>
           <p:cNvSpPr txBox="1"/>
           <p:nvPr/>
         </p:nvSpPr>
@@ -7577,7 +7611,7 @@
       </p:sp>
       <p:sp>
         <p:nvSpPr>
-          <p:cNvPr id="60" name="Rectangle 59"/>
+          <p:cNvPr id="61" name="Rectangle 60"/>
           <p:cNvSpPr/>
           <p:nvPr/>
         </p:nvSpPr>
@@ -7622,7 +7656,7 @@
       </p:sp>
       <p:sp>
         <p:nvSpPr>
-          <p:cNvPr id="61" name="TextBox 60"/>
+          <p:cNvPr id="62" name="TextBox 61"/>
           <p:cNvSpPr txBox="1"/>
           <p:nvPr/>
         </p:nvSpPr>
@@ -7656,7 +7690,7 @@
       </p:sp>
       <p:sp>
         <p:nvSpPr>
-          <p:cNvPr id="62" name="Rectangle 61"/>
+          <p:cNvPr id="63" name="Rectangle 62"/>
           <p:cNvSpPr/>
           <p:nvPr/>
         </p:nvSpPr>
@@ -7701,7 +7735,7 @@
       </p:sp>
       <p:sp>
         <p:nvSpPr>
-          <p:cNvPr id="63" name="TextBox 62"/>
+          <p:cNvPr id="64" name="TextBox 63"/>
           <p:cNvSpPr txBox="1"/>
           <p:nvPr/>
         </p:nvSpPr>
@@ -7735,7 +7769,7 @@
       </p:sp>
       <p:sp>
         <p:nvSpPr>
-          <p:cNvPr id="64" name="Rectangle 63"/>
+          <p:cNvPr id="65" name="Rectangle 64"/>
           <p:cNvSpPr/>
           <p:nvPr/>
         </p:nvSpPr>
@@ -7780,7 +7814,7 @@
       </p:sp>
       <p:sp>
         <p:nvSpPr>
-          <p:cNvPr id="65" name="TextBox 64"/>
+          <p:cNvPr id="66" name="TextBox 65"/>
           <p:cNvSpPr txBox="1"/>
           <p:nvPr/>
         </p:nvSpPr>
@@ -7814,7 +7848,7 @@
       </p:sp>
       <p:sp>
         <p:nvSpPr>
-          <p:cNvPr id="66" name="Rectangle 65"/>
+          <p:cNvPr id="67" name="Rectangle 66"/>
           <p:cNvSpPr/>
           <p:nvPr/>
         </p:nvSpPr>
@@ -7859,7 +7893,7 @@
       </p:sp>
       <p:sp>
         <p:nvSpPr>
-          <p:cNvPr id="67" name="TextBox 66"/>
+          <p:cNvPr id="68" name="TextBox 67"/>
           <p:cNvSpPr txBox="1"/>
           <p:nvPr/>
         </p:nvSpPr>
@@ -7883,17 +7917,17 @@
             <a:r>
               <a:rPr sz="1200" b="0" i="0">
                 <a:solidFill>
-                  <a:srgbClr val="BE202E"/>
-                </a:solidFill>
-              </a:rPr>
-              <a:t>❌</a:t>
-            </a:r>
-          </a:p>
-        </p:txBody>
-      </p:sp>
-      <p:sp>
-        <p:nvSpPr>
-          <p:cNvPr id="68" name="Rectangle 67"/>
+                  <a:srgbClr val="0C72EE"/>
+                </a:solidFill>
+              </a:rPr>
+              <a:t>partial</a:t>
+            </a:r>
+          </a:p>
+        </p:txBody>
+      </p:sp>
+      <p:sp>
+        <p:nvSpPr>
+          <p:cNvPr id="69" name="Rectangle 68"/>
           <p:cNvSpPr/>
           <p:nvPr/>
         </p:nvSpPr>
@@ -7938,7 +7972,7 @@
       </p:sp>
       <p:sp>
         <p:nvSpPr>
-          <p:cNvPr id="69" name="TextBox 68"/>
+          <p:cNvPr id="70" name="TextBox 69"/>
           <p:cNvSpPr txBox="1"/>
           <p:nvPr/>
         </p:nvSpPr>
@@ -7972,7 +8006,7 @@
       </p:sp>
       <p:sp>
         <p:nvSpPr>
-          <p:cNvPr id="70" name="Rectangle 69"/>
+          <p:cNvPr id="71" name="Rectangle 70"/>
           <p:cNvSpPr/>
           <p:nvPr/>
         </p:nvSpPr>
@@ -8017,7 +8051,7 @@
       </p:sp>
       <p:sp>
         <p:nvSpPr>
-          <p:cNvPr id="71" name="TextBox 70"/>
+          <p:cNvPr id="72" name="TextBox 71"/>
           <p:cNvSpPr txBox="1"/>
           <p:nvPr/>
         </p:nvSpPr>
@@ -8051,7 +8085,7 @@
       </p:sp>
       <p:sp>
         <p:nvSpPr>
-          <p:cNvPr id="72" name="Rectangle 71"/>
+          <p:cNvPr id="73" name="Rectangle 72"/>
           <p:cNvSpPr/>
           <p:nvPr/>
         </p:nvSpPr>
@@ -8096,7 +8130,7 @@
       </p:sp>
       <p:sp>
         <p:nvSpPr>
-          <p:cNvPr id="73" name="TextBox 72"/>
+          <p:cNvPr id="74" name="TextBox 73"/>
           <p:cNvSpPr txBox="1"/>
           <p:nvPr/>
         </p:nvSpPr>
@@ -8130,7 +8164,7 @@
       </p:sp>
       <p:sp>
         <p:nvSpPr>
-          <p:cNvPr id="74" name="Rectangle 73"/>
+          <p:cNvPr id="75" name="Rectangle 74"/>
           <p:cNvSpPr/>
           <p:nvPr/>
         </p:nvSpPr>
@@ -8175,7 +8209,7 @@
       </p:sp>
       <p:sp>
         <p:nvSpPr>
-          <p:cNvPr id="75" name="TextBox 74"/>
+          <p:cNvPr id="76" name="TextBox 75"/>
           <p:cNvSpPr txBox="1"/>
           <p:nvPr/>
         </p:nvSpPr>
@@ -8209,7 +8243,7 @@
       </p:sp>
       <p:sp>
         <p:nvSpPr>
-          <p:cNvPr id="76" name="Rectangle 75"/>
+          <p:cNvPr id="77" name="Rectangle 76"/>
           <p:cNvSpPr/>
           <p:nvPr/>
         </p:nvSpPr>
@@ -8254,7 +8288,7 @@
       </p:sp>
       <p:sp>
         <p:nvSpPr>
-          <p:cNvPr id="77" name="TextBox 76"/>
+          <p:cNvPr id="78" name="TextBox 77"/>
           <p:cNvSpPr txBox="1"/>
           <p:nvPr/>
         </p:nvSpPr>
@@ -8281,14 +8315,14 @@
                   <a:srgbClr val="1A1B1C"/>
                 </a:solidFill>
               </a:rPr>
-              <a:t>On-Premise Model</a:t>
-            </a:r>
-          </a:p>
-        </p:txBody>
-      </p:sp>
-      <p:sp>
-        <p:nvSpPr>
-          <p:cNvPr id="78" name="Rectangle 77"/>
+              <a:t>On-Premise / Local Model</a:t>
+            </a:r>
+          </a:p>
+        </p:txBody>
+      </p:sp>
+      <p:sp>
+        <p:nvSpPr>
+          <p:cNvPr id="79" name="Rectangle 78"/>
           <p:cNvSpPr/>
           <p:nvPr/>
         </p:nvSpPr>
@@ -8333,7 +8367,7 @@
       </p:sp>
       <p:sp>
         <p:nvSpPr>
-          <p:cNvPr id="79" name="TextBox 78"/>
+          <p:cNvPr id="80" name="TextBox 79"/>
           <p:cNvSpPr txBox="1"/>
           <p:nvPr/>
         </p:nvSpPr>
@@ -8367,7 +8401,7 @@
       </p:sp>
       <p:sp>
         <p:nvSpPr>
-          <p:cNvPr id="80" name="Rectangle 79"/>
+          <p:cNvPr id="81" name="Rectangle 80"/>
           <p:cNvSpPr/>
           <p:nvPr/>
         </p:nvSpPr>
@@ -8412,7 +8446,7 @@
       </p:sp>
       <p:sp>
         <p:nvSpPr>
-          <p:cNvPr id="81" name="TextBox 80"/>
+          <p:cNvPr id="82" name="TextBox 81"/>
           <p:cNvSpPr txBox="1"/>
           <p:nvPr/>
         </p:nvSpPr>
@@ -8446,7 +8480,7 @@
       </p:sp>
       <p:sp>
         <p:nvSpPr>
-          <p:cNvPr id="82" name="Rectangle 81"/>
+          <p:cNvPr id="83" name="Rectangle 82"/>
           <p:cNvSpPr/>
           <p:nvPr/>
         </p:nvSpPr>
@@ -8491,7 +8525,7 @@
       </p:sp>
       <p:sp>
         <p:nvSpPr>
-          <p:cNvPr id="83" name="TextBox 82"/>
+          <p:cNvPr id="84" name="TextBox 83"/>
           <p:cNvSpPr txBox="1"/>
           <p:nvPr/>
         </p:nvSpPr>
@@ -8525,7 +8559,7 @@
       </p:sp>
       <p:sp>
         <p:nvSpPr>
-          <p:cNvPr id="84" name="Rectangle 83"/>
+          <p:cNvPr id="85" name="Rectangle 84"/>
           <p:cNvSpPr/>
           <p:nvPr/>
         </p:nvSpPr>
@@ -8570,7 +8604,7 @@
       </p:sp>
       <p:sp>
         <p:nvSpPr>
-          <p:cNvPr id="85" name="TextBox 84"/>
+          <p:cNvPr id="86" name="TextBox 85"/>
           <p:cNvSpPr txBox="1"/>
           <p:nvPr/>
         </p:nvSpPr>
@@ -8604,7 +8638,7 @@
       </p:sp>
       <p:sp>
         <p:nvSpPr>
-          <p:cNvPr id="86" name="Rectangle 85"/>
+          <p:cNvPr id="87" name="Rectangle 86"/>
           <p:cNvSpPr/>
           <p:nvPr/>
         </p:nvSpPr>
@@ -8649,7 +8683,7 @@
       </p:sp>
       <p:sp>
         <p:nvSpPr>
-          <p:cNvPr id="87" name="TextBox 86"/>
+          <p:cNvPr id="88" name="TextBox 87"/>
           <p:cNvSpPr txBox="1"/>
           <p:nvPr/>
         </p:nvSpPr>
@@ -8683,7 +8717,7 @@
       </p:sp>
       <p:sp>
         <p:nvSpPr>
-          <p:cNvPr id="88" name="Rectangle 87"/>
+          <p:cNvPr id="89" name="Rectangle 88"/>
           <p:cNvSpPr/>
           <p:nvPr/>
         </p:nvSpPr>
@@ -8728,7 +8762,7 @@
       </p:sp>
       <p:sp>
         <p:nvSpPr>
-          <p:cNvPr id="89" name="TextBox 88"/>
+          <p:cNvPr id="90" name="TextBox 89"/>
           <p:cNvSpPr txBox="1"/>
           <p:nvPr/>
         </p:nvSpPr>
@@ -8755,14 +8789,14 @@
                   <a:srgbClr val="1A1B1C"/>
                 </a:solidFill>
               </a:rPr>
-              <a:t>No MMP SDK Required</a:t>
-            </a:r>
-          </a:p>
-        </p:txBody>
-      </p:sp>
-      <p:sp>
-        <p:nvSpPr>
-          <p:cNvPr id="90" name="Rectangle 89"/>
+              <a:t>No SDK / MMP Required</a:t>
+            </a:r>
+          </a:p>
+        </p:txBody>
+      </p:sp>
+      <p:sp>
+        <p:nvSpPr>
+          <p:cNvPr id="91" name="Rectangle 90"/>
           <p:cNvSpPr/>
           <p:nvPr/>
         </p:nvSpPr>
@@ -8807,7 +8841,7 @@
       </p:sp>
       <p:sp>
         <p:nvSpPr>
-          <p:cNvPr id="91" name="TextBox 90"/>
+          <p:cNvPr id="92" name="TextBox 91"/>
           <p:cNvSpPr txBox="1"/>
           <p:nvPr/>
         </p:nvSpPr>
@@ -8841,7 +8875,7 @@
       </p:sp>
       <p:sp>
         <p:nvSpPr>
-          <p:cNvPr id="92" name="Rectangle 91"/>
+          <p:cNvPr id="93" name="Rectangle 92"/>
           <p:cNvSpPr/>
           <p:nvPr/>
         </p:nvSpPr>
@@ -8886,7 +8920,7 @@
       </p:sp>
       <p:sp>
         <p:nvSpPr>
-          <p:cNvPr id="93" name="TextBox 92"/>
+          <p:cNvPr id="94" name="TextBox 93"/>
           <p:cNvSpPr txBox="1"/>
           <p:nvPr/>
         </p:nvSpPr>
@@ -8920,7 +8954,7 @@
       </p:sp>
       <p:sp>
         <p:nvSpPr>
-          <p:cNvPr id="94" name="Rectangle 93"/>
+          <p:cNvPr id="95" name="Rectangle 94"/>
           <p:cNvSpPr/>
           <p:nvPr/>
         </p:nvSpPr>
@@ -8965,7 +8999,7 @@
       </p:sp>
       <p:sp>
         <p:nvSpPr>
-          <p:cNvPr id="95" name="TextBox 94"/>
+          <p:cNvPr id="96" name="TextBox 95"/>
           <p:cNvSpPr txBox="1"/>
           <p:nvPr/>
         </p:nvSpPr>
@@ -8999,7 +9033,7 @@
       </p:sp>
       <p:sp>
         <p:nvSpPr>
-          <p:cNvPr id="96" name="Rectangle 95"/>
+          <p:cNvPr id="97" name="Rectangle 96"/>
           <p:cNvSpPr/>
           <p:nvPr/>
         </p:nvSpPr>
@@ -9044,7 +9078,7 @@
       </p:sp>
       <p:sp>
         <p:nvSpPr>
-          <p:cNvPr id="97" name="TextBox 96"/>
+          <p:cNvPr id="98" name="TextBox 97"/>
           <p:cNvSpPr txBox="1"/>
           <p:nvPr/>
         </p:nvSpPr>
@@ -9078,7 +9112,7 @@
       </p:sp>
       <p:sp>
         <p:nvSpPr>
-          <p:cNvPr id="98" name="Rectangle 97"/>
+          <p:cNvPr id="99" name="Rectangle 98"/>
           <p:cNvSpPr/>
           <p:nvPr/>
         </p:nvSpPr>
@@ -9123,7 +9157,7 @@
       </p:sp>
       <p:sp>
         <p:nvSpPr>
-          <p:cNvPr id="99" name="TextBox 98"/>
+          <p:cNvPr id="100" name="TextBox 99"/>
           <p:cNvSpPr txBox="1"/>
           <p:nvPr/>
         </p:nvSpPr>
@@ -9157,7 +9191,7 @@
       </p:sp>
       <p:sp>
         <p:nvSpPr>
-          <p:cNvPr id="100" name="Rectangle 99"/>
+          <p:cNvPr id="101" name="Rectangle 100"/>
           <p:cNvSpPr/>
           <p:nvPr/>
         </p:nvSpPr>
@@ -9202,7 +9236,7 @@
       </p:sp>
       <p:sp>
         <p:nvSpPr>
-          <p:cNvPr id="101" name="TextBox 100"/>
+          <p:cNvPr id="102" name="TextBox 101"/>
           <p:cNvSpPr txBox="1"/>
           <p:nvPr/>
         </p:nvSpPr>
@@ -9236,7 +9270,7 @@
       </p:sp>
       <p:sp>
         <p:nvSpPr>
-          <p:cNvPr id="102" name="Rectangle 101"/>
+          <p:cNvPr id="103" name="Rectangle 102"/>
           <p:cNvSpPr/>
           <p:nvPr/>
         </p:nvSpPr>
@@ -9281,7 +9315,7 @@
       </p:sp>
       <p:sp>
         <p:nvSpPr>
-          <p:cNvPr id="103" name="TextBox 102"/>
+          <p:cNvPr id="104" name="TextBox 103"/>
           <p:cNvSpPr txBox="1"/>
           <p:nvPr/>
         </p:nvSpPr>
@@ -9315,7 +9349,7 @@
       </p:sp>
       <p:sp>
         <p:nvSpPr>
-          <p:cNvPr id="104" name="Rectangle 103"/>
+          <p:cNvPr id="105" name="Rectangle 104"/>
           <p:cNvSpPr/>
           <p:nvPr/>
         </p:nvSpPr>
@@ -9360,7 +9394,7 @@
       </p:sp>
       <p:sp>
         <p:nvSpPr>
-          <p:cNvPr id="105" name="TextBox 104"/>
+          <p:cNvPr id="106" name="TextBox 105"/>
           <p:cNvSpPr txBox="1"/>
           <p:nvPr/>
         </p:nvSpPr>
@@ -9394,7 +9428,7 @@
       </p:sp>
       <p:sp>
         <p:nvSpPr>
-          <p:cNvPr id="106" name="Rectangle 105"/>
+          <p:cNvPr id="107" name="Rectangle 106"/>
           <p:cNvSpPr/>
           <p:nvPr/>
         </p:nvSpPr>
@@ -9439,7 +9473,7 @@
       </p:sp>
       <p:sp>
         <p:nvSpPr>
-          <p:cNvPr id="107" name="TextBox 106"/>
+          <p:cNvPr id="108" name="TextBox 107"/>
           <p:cNvSpPr txBox="1"/>
           <p:nvPr/>
         </p:nvSpPr>
@@ -9473,7 +9507,7 @@
       </p:sp>
       <p:sp>
         <p:nvSpPr>
-          <p:cNvPr id="108" name="Rectangle 107"/>
+          <p:cNvPr id="109" name="Rectangle 108"/>
           <p:cNvSpPr/>
           <p:nvPr/>
         </p:nvSpPr>
@@ -9518,7 +9552,7 @@
       </p:sp>
       <p:sp>
         <p:nvSpPr>
-          <p:cNvPr id="109" name="TextBox 108"/>
+          <p:cNvPr id="110" name="TextBox 109"/>
           <p:cNvSpPr txBox="1"/>
           <p:nvPr/>
         </p:nvSpPr>
@@ -9552,7 +9586,7 @@
       </p:sp>
       <p:sp>
         <p:nvSpPr>
-          <p:cNvPr id="110" name="Rectangle 109"/>
+          <p:cNvPr id="111" name="Rectangle 110"/>
           <p:cNvSpPr/>
           <p:nvPr/>
         </p:nvSpPr>
@@ -9597,7 +9631,7 @@
       </p:sp>
       <p:sp>
         <p:nvSpPr>
-          <p:cNvPr id="111" name="TextBox 110"/>
+          <p:cNvPr id="112" name="TextBox 111"/>
           <p:cNvSpPr txBox="1"/>
           <p:nvPr/>
         </p:nvSpPr>

</xml_diff>